<commit_message>
Docs sincronizzati, LICENSE, Makefile, test unitari, fix slide deck
- README: 15 run (era 5), 23 slide (era 20), nota volumi dataset
  (25,979 match -> 1.5M righe post-parsing), sezione licenza/attribuzione
  ODbL, struttura repo aggiornata
- benchmark/README: documenta significance.csv, db_config.json, plans/,
  ablation a matrice, sensitivity, metodologia a 8 step
- LICENSE (MIT) + nota dataset ODbL non ridistribuito
- Makefile: entry-point unico (venv/etl/benchmark/report/test)
- tests/: 11 test pytest su normalize_rows, verbosity, bootstrap (tutti verdi)
- Slide deck: slide 18 "10 runs" (era 5), rimossa takeaway bar residua
  dalle slide 20 e 23, box tuning aggiornato con esito sensitivity,
  speaker notes con numeri correnti e riconciliazione proposal
- .gitignore: esclusi materiale del corso, file di prova, .pytest_cache

Co-Authored-By: Claude Fable 5 <noreply@anthropic.com>
</commit_message>
<xml_diff>
--- a/Presentation_DM_DAngelica_Leone.pptx
+++ b/Presentation_DM_DAngelica_Leone.pptx
@@ -1211,7 +1211,7 @@
           <a:lstStyle/>
           <a:p>
             <a:r>
-              <a:t>Index ablation. Real numbers: 'Drop ix_lineup_player from Postgres: 3.6 ms → 11.3 ms, 3.18x slowdown. Drop player_name_idx from Neo4j: 5.1 → 7.8 ms, 1.55x slowdown. Indexes are NOT decoration.'</a:t>
+              <a:t>Index ablation, numeri del run 20260524 (10 run per fase): drop di ix_lineup_player su Postgres Q08: 3.2 -&gt; 11.2 ms, 3.48x slowdown. Drop di player_name_idx su Neo4j Q08: 3.9 -&gt; 7.4 ms, 1.91x. La matrice completa (7 coppie) e' nel report e include un controesempio: togliere team_name_idx su Q06 la VELOCIZZA (0.62x) — non ogni indice aiuta. Indexes are NOT decoration, ma vanno misurati.</a:t>
             </a:r>
           </a:p>
         </p:txBody>
@@ -1851,7 +1851,7 @@
           <a:lstStyle/>
           <a:p>
             <a:r>
-              <a:t>Dataset highlights. 26k matches, 917k events from XML parsing — emphasize that data quality matters: we'll see in 5 slides how the integration of XML events created challenges.</a:t>
+              <a:t>Dataset highlights. 26k matches, 917k events from XML parsing — emphasize that data quality matters: we'll see in 5 slides how the integration of XML events created challenges. Se chiedono dei '~300,000 records' citati nella proposal: il sorgente ha 25,979 match e ~220k righe totali fra le tabelle; dopo il parsing XML il progetto carica ~1.5M righe (917,815 eventi + 542,281 formazioni) in entrambi i sistemi — piu' dati di quanto promesso, meglio strutturati.</a:t>
             </a:r>
           </a:p>
         </p:txBody>
@@ -3404,7 +3404,7 @@
                 <a:ea typeface="Calibri" pitchFamily="34" charset="-122"/>
                 <a:cs typeface="Calibri" pitchFamily="34" charset="-120"/>
               </a:rPr>
-              <a:t>Avoids cold-cache bias on both DBs; medians computed only on the next 5 runs.</a:t>
+              <a:t>Avoids cold-cache bias on both DBs; medians computed only on the next 15 runs.</a:t>
             </a:r>
             <a:endParaRPr lang="en-US" sz="1200" dirty="0"/>
           </a:p>
@@ -3586,7 +3586,7 @@
                 <a:ea typeface="Calibri" pitchFamily="34" charset="-122"/>
                 <a:cs typeface="Calibri" pitchFamily="34" charset="-120"/>
               </a:rPr>
-              <a:t>Median + IQR</a:t>
+              <a:t>Median + CI + Significance</a:t>
             </a:r>
             <a:endParaRPr lang="en-US" sz="1800" dirty="0"/>
           </a:p>
@@ -3625,7 +3625,7 @@
                 <a:ea typeface="Calibri" pitchFamily="34" charset="-122"/>
                 <a:cs typeface="Calibri" pitchFamily="34" charset="-120"/>
               </a:rPr>
-              <a:t>Median is robust to outliers. We also report min, max, IQR.</a:t>
+              <a:t>Median with bootstrap 95% CI (10k resamples). Significance via Mann-Whitney U (alpha = 0.05). 11/12 differences are statistically significant.</a:t>
             </a:r>
             <a:endParaRPr lang="en-US" sz="1200" dirty="0"/>
           </a:p>
@@ -5753,7 +5753,7 @@
                 <a:ea typeface="Calibri" pitchFamily="34" charset="-122"/>
                 <a:cs typeface="Calibri" pitchFamily="34" charset="-120"/>
               </a:rPr>
-              <a:t>All 10 read queries produced equivalent results in both systems</a:t>
+              <a:t>All 10 read queries equivalent  ·  * = significant (p &lt; 0.05, Mann-Whitney U)  ·  11/12 significant</a:t>
             </a:r>
             <a:endParaRPr lang="en-US" sz="1300" dirty="0"/>
           </a:p>
@@ -6510,7 +6510,7 @@
                           <a:ea typeface="Consolas" pitchFamily="34" charset="-122"/>
                           <a:cs typeface="Consolas" pitchFamily="34" charset="-120"/>
                         </a:rPr>
-                        <a:t>15.6</a:t>
+                        <a:t>10.8</a:t>
                       </a:r>
                       <a:endParaRPr lang="en-US" sz="1100" dirty="0">
                         <a:latin typeface="Consolas" charset="0"/>
@@ -6575,7 +6575,7 @@
                           <a:ea typeface="Consolas" pitchFamily="34" charset="-122"/>
                           <a:cs typeface="Consolas" pitchFamily="34" charset="-120"/>
                         </a:rPr>
-                        <a:t>9.1</a:t>
+                        <a:t>13.2</a:t>
                       </a:r>
                       <a:endParaRPr lang="en-US" sz="1100" dirty="0">
                         <a:latin typeface="Consolas" charset="0"/>
@@ -6640,7 +6640,7 @@
                           <a:ea typeface="Calibri" pitchFamily="34" charset="-122"/>
                           <a:cs typeface="Calibri" pitchFamily="34" charset="-120"/>
                         </a:rPr>
-                        <a:t>Neo4j</a:t>
+                        <a:t>Postgres</a:t>
                       </a:r>
                       <a:endParaRPr lang="en-US" sz="1100" dirty="0">
                         <a:latin typeface="Calibri" charset="0"/>
@@ -6705,7 +6705,7 @@
                           <a:ea typeface="Consolas" pitchFamily="34" charset="-122"/>
                           <a:cs typeface="Consolas" pitchFamily="34" charset="-120"/>
                         </a:rPr>
-                        <a:t>1.71x</a:t>
+                        <a:t>1.23x</a:t>
                       </a:r>
                       <a:endParaRPr lang="en-US" sz="1100" dirty="0">
                         <a:latin typeface="Consolas" charset="0"/>
@@ -6967,7 +6967,7 @@
                           <a:ea typeface="Consolas" pitchFamily="34" charset="-122"/>
                           <a:cs typeface="Consolas" pitchFamily="34" charset="-120"/>
                         </a:rPr>
-                        <a:t>3.8</a:t>
+                        <a:t>7.4</a:t>
                       </a:r>
                       <a:endParaRPr lang="en-US" sz="1100" dirty="0">
                         <a:latin typeface="Consolas" charset="0"/>
@@ -7032,7 +7032,7 @@
                           <a:ea typeface="Consolas" pitchFamily="34" charset="-122"/>
                           <a:cs typeface="Consolas" pitchFamily="34" charset="-120"/>
                         </a:rPr>
-                        <a:t>5.7</a:t>
+                        <a:t>8.8</a:t>
                       </a:r>
                       <a:endParaRPr lang="en-US" sz="1100" dirty="0">
                         <a:latin typeface="Consolas" charset="0"/>
@@ -7097,7 +7097,7 @@
                           <a:ea typeface="Calibri" pitchFamily="34" charset="-122"/>
                           <a:cs typeface="Calibri" pitchFamily="34" charset="-120"/>
                         </a:rPr>
-                        <a:t>Postgres</a:t>
+                        <a:t>Postgres*</a:t>
                       </a:r>
                       <a:endParaRPr lang="en-US" sz="1100" dirty="0">
                         <a:latin typeface="Calibri" charset="0"/>
@@ -7162,7 +7162,7 @@
                           <a:ea typeface="Consolas" pitchFamily="34" charset="-122"/>
                           <a:cs typeface="Consolas" pitchFamily="34" charset="-120"/>
                         </a:rPr>
-                        <a:t>1.52x</a:t>
+                        <a:t>1.19x</a:t>
                       </a:r>
                       <a:endParaRPr lang="en-US" sz="1100" dirty="0">
                         <a:latin typeface="Consolas" charset="0"/>
@@ -7424,7 +7424,7 @@
                           <a:ea typeface="Consolas" pitchFamily="34" charset="-122"/>
                           <a:cs typeface="Consolas" pitchFamily="34" charset="-120"/>
                         </a:rPr>
-                        <a:t>3.9</a:t>
+                        <a:t>3.8</a:t>
                       </a:r>
                       <a:endParaRPr lang="en-US" sz="1100" dirty="0">
                         <a:latin typeface="Consolas" charset="0"/>
@@ -7489,7 +7489,7 @@
                           <a:ea typeface="Consolas" pitchFamily="34" charset="-122"/>
                           <a:cs typeface="Consolas" pitchFamily="34" charset="-120"/>
                         </a:rPr>
-                        <a:t>5.6</a:t>
+                        <a:t>7.9</a:t>
                       </a:r>
                       <a:endParaRPr lang="en-US" sz="1100" dirty="0">
                         <a:latin typeface="Consolas" charset="0"/>
@@ -7554,7 +7554,7 @@
                           <a:ea typeface="Calibri" pitchFamily="34" charset="-122"/>
                           <a:cs typeface="Calibri" pitchFamily="34" charset="-120"/>
                         </a:rPr>
-                        <a:t>Postgres</a:t>
+                        <a:t>Postgres*</a:t>
                       </a:r>
                       <a:endParaRPr lang="en-US" sz="1100" dirty="0">
                         <a:latin typeface="Calibri" charset="0"/>
@@ -7619,7 +7619,7 @@
                           <a:ea typeface="Consolas" pitchFamily="34" charset="-122"/>
                           <a:cs typeface="Consolas" pitchFamily="34" charset="-120"/>
                         </a:rPr>
-                        <a:t>1.45x</a:t>
+                        <a:t>2.11x</a:t>
                       </a:r>
                       <a:endParaRPr lang="en-US" sz="1100" dirty="0">
                         <a:latin typeface="Consolas" charset="0"/>
@@ -7881,7 +7881,7 @@
                           <a:ea typeface="Consolas" pitchFamily="34" charset="-122"/>
                           <a:cs typeface="Consolas" pitchFamily="34" charset="-120"/>
                         </a:rPr>
-                        <a:t>16.8</a:t>
+                        <a:t>12.5</a:t>
                       </a:r>
                       <a:endParaRPr lang="en-US" sz="1100" dirty="0">
                         <a:latin typeface="Consolas" charset="0"/>
@@ -7946,7 +7946,7 @@
                           <a:ea typeface="Consolas" pitchFamily="34" charset="-122"/>
                           <a:cs typeface="Consolas" pitchFamily="34" charset="-120"/>
                         </a:rPr>
-                        <a:t>24.5</a:t>
+                        <a:t>14.7</a:t>
                       </a:r>
                       <a:endParaRPr lang="en-US" sz="1100" dirty="0">
                         <a:latin typeface="Consolas" charset="0"/>
@@ -8011,7 +8011,7 @@
                           <a:ea typeface="Calibri" pitchFamily="34" charset="-122"/>
                           <a:cs typeface="Calibri" pitchFamily="34" charset="-120"/>
                         </a:rPr>
-                        <a:t>Postgres</a:t>
+                        <a:t>Postgres*</a:t>
                       </a:r>
                       <a:endParaRPr lang="en-US" sz="1100" dirty="0">
                         <a:latin typeface="Calibri" charset="0"/>
@@ -8076,7 +8076,7 @@
                           <a:ea typeface="Consolas" pitchFamily="34" charset="-122"/>
                           <a:cs typeface="Consolas" pitchFamily="34" charset="-120"/>
                         </a:rPr>
-                        <a:t>1.46x</a:t>
+                        <a:t>1.18x</a:t>
                       </a:r>
                       <a:endParaRPr lang="en-US" sz="1100" dirty="0">
                         <a:latin typeface="Consolas" charset="0"/>
@@ -8338,7 +8338,7 @@
                           <a:ea typeface="Consolas" pitchFamily="34" charset="-122"/>
                           <a:cs typeface="Consolas" pitchFamily="34" charset="-120"/>
                         </a:rPr>
-                        <a:t>27.6</a:t>
+                        <a:t>55.4</a:t>
                       </a:r>
                       <a:endParaRPr lang="en-US" sz="1100" dirty="0">
                         <a:latin typeface="Consolas" charset="0"/>
@@ -8403,7 +8403,7 @@
                           <a:ea typeface="Consolas" pitchFamily="34" charset="-122"/>
                           <a:cs typeface="Consolas" pitchFamily="34" charset="-120"/>
                         </a:rPr>
-                        <a:t>52.3</a:t>
+                        <a:t>36.0</a:t>
                       </a:r>
                       <a:endParaRPr lang="en-US" sz="1100" dirty="0">
                         <a:latin typeface="Consolas" charset="0"/>
@@ -8468,7 +8468,7 @@
                           <a:ea typeface="Calibri" pitchFamily="34" charset="-122"/>
                           <a:cs typeface="Calibri" pitchFamily="34" charset="-120"/>
                         </a:rPr>
-                        <a:t>Postgres</a:t>
+                        <a:t>Neo4j*</a:t>
                       </a:r>
                       <a:endParaRPr lang="en-US" sz="1100" dirty="0">
                         <a:latin typeface="Calibri" charset="0"/>
@@ -8533,7 +8533,7 @@
                           <a:ea typeface="Consolas" pitchFamily="34" charset="-122"/>
                           <a:cs typeface="Consolas" pitchFamily="34" charset="-120"/>
                         </a:rPr>
-                        <a:t>1.89x</a:t>
+                        <a:t>1.54x</a:t>
                       </a:r>
                       <a:endParaRPr lang="en-US" sz="1100" dirty="0">
                         <a:latin typeface="Consolas" charset="0"/>
@@ -8795,7 +8795,7 @@
                           <a:ea typeface="Consolas" pitchFamily="34" charset="-122"/>
                           <a:cs typeface="Consolas" pitchFamily="34" charset="-120"/>
                         </a:rPr>
-                        <a:t>24.4</a:t>
+                        <a:t>20.2</a:t>
                       </a:r>
                       <a:endParaRPr lang="en-US" sz="1100" dirty="0">
                         <a:latin typeface="Consolas" charset="0"/>
@@ -8860,7 +8860,7 @@
                           <a:ea typeface="Consolas" pitchFamily="34" charset="-122"/>
                           <a:cs typeface="Consolas" pitchFamily="34" charset="-120"/>
                         </a:rPr>
-                        <a:t>8.8</a:t>
+                        <a:t>6.3</a:t>
                       </a:r>
                       <a:endParaRPr lang="en-US" sz="1100" dirty="0">
                         <a:latin typeface="Consolas" charset="0"/>
@@ -8925,7 +8925,7 @@
                           <a:ea typeface="Calibri" pitchFamily="34" charset="-122"/>
                           <a:cs typeface="Calibri" pitchFamily="34" charset="-120"/>
                         </a:rPr>
-                        <a:t>Neo4j</a:t>
+                        <a:t>Neo4j*</a:t>
                       </a:r>
                       <a:endParaRPr lang="en-US" sz="1100" dirty="0">
                         <a:latin typeface="Calibri" charset="0"/>
@@ -8990,7 +8990,7 @@
                           <a:ea typeface="Consolas" pitchFamily="34" charset="-122"/>
                           <a:cs typeface="Consolas" pitchFamily="34" charset="-120"/>
                         </a:rPr>
-                        <a:t>2.78x</a:t>
+                        <a:t>3.24x</a:t>
                       </a:r>
                       <a:endParaRPr lang="en-US" sz="1100" dirty="0">
                         <a:latin typeface="Consolas" charset="0"/>
@@ -9252,7 +9252,7 @@
                           <a:ea typeface="Consolas" pitchFamily="34" charset="-122"/>
                           <a:cs typeface="Consolas" pitchFamily="34" charset="-120"/>
                         </a:rPr>
-                        <a:t>1283.5</a:t>
+                        <a:t>1277.1</a:t>
                       </a:r>
                       <a:endParaRPr lang="en-US" sz="1100" dirty="0">
                         <a:latin typeface="Consolas" charset="0"/>
@@ -9317,7 +9317,7 @@
                           <a:ea typeface="Consolas" pitchFamily="34" charset="-122"/>
                           <a:cs typeface="Consolas" pitchFamily="34" charset="-120"/>
                         </a:rPr>
-                        <a:t>201.0</a:t>
+                        <a:t>204.9</a:t>
                       </a:r>
                       <a:endParaRPr lang="en-US" sz="1100" dirty="0">
                         <a:latin typeface="Consolas" charset="0"/>
@@ -9382,7 +9382,7 @@
                           <a:ea typeface="Calibri" pitchFamily="34" charset="-122"/>
                           <a:cs typeface="Calibri" pitchFamily="34" charset="-120"/>
                         </a:rPr>
-                        <a:t>Neo4j</a:t>
+                        <a:t>Neo4j*</a:t>
                       </a:r>
                       <a:endParaRPr lang="en-US" sz="1100" dirty="0">
                         <a:latin typeface="Calibri" charset="0"/>
@@ -9447,7 +9447,7 @@
                           <a:ea typeface="Consolas" pitchFamily="34" charset="-122"/>
                           <a:cs typeface="Consolas" pitchFamily="34" charset="-120"/>
                         </a:rPr>
-                        <a:t>6.39x</a:t>
+                        <a:t>6.23x</a:t>
                       </a:r>
                       <a:endParaRPr lang="en-US" sz="1100" dirty="0">
                         <a:latin typeface="Consolas" charset="0"/>
@@ -9709,7 +9709,7 @@
                           <a:ea typeface="Consolas" pitchFamily="34" charset="-122"/>
                           <a:cs typeface="Consolas" pitchFamily="34" charset="-120"/>
                         </a:rPr>
-                        <a:t>5.6</a:t>
+                        <a:t>5.9</a:t>
                       </a:r>
                       <a:endParaRPr lang="en-US" sz="1100" dirty="0">
                         <a:latin typeface="Consolas" charset="0"/>
@@ -9839,7 +9839,7 @@
                           <a:ea typeface="Calibri" pitchFamily="34" charset="-122"/>
                           <a:cs typeface="Calibri" pitchFamily="34" charset="-120"/>
                         </a:rPr>
-                        <a:t>Neo4j</a:t>
+                        <a:t>Neo4j*</a:t>
                       </a:r>
                       <a:endParaRPr lang="en-US" sz="1100" dirty="0">
                         <a:latin typeface="Calibri" charset="0"/>
@@ -9904,7 +9904,7 @@
                           <a:ea typeface="Consolas" pitchFamily="34" charset="-122"/>
                           <a:cs typeface="Consolas" pitchFamily="34" charset="-120"/>
                         </a:rPr>
-                        <a:t>1.61x</a:t>
+                        <a:t>1.69x</a:t>
                       </a:r>
                       <a:endParaRPr lang="en-US" sz="1100" dirty="0">
                         <a:latin typeface="Consolas" charset="0"/>
@@ -10166,7 +10166,7 @@
                           <a:ea typeface="Consolas" pitchFamily="34" charset="-122"/>
                           <a:cs typeface="Consolas" pitchFamily="34" charset="-120"/>
                         </a:rPr>
-                        <a:t>36.3</a:t>
+                        <a:t>30.6</a:t>
                       </a:r>
                       <a:endParaRPr lang="en-US" sz="1100" dirty="0">
                         <a:latin typeface="Consolas" charset="0"/>
@@ -10231,7 +10231,7 @@
                           <a:ea typeface="Consolas" pitchFamily="34" charset="-122"/>
                           <a:cs typeface="Consolas" pitchFamily="34" charset="-120"/>
                         </a:rPr>
-                        <a:t>66.9</a:t>
+                        <a:t>68.8</a:t>
                       </a:r>
                       <a:endParaRPr lang="en-US" sz="1100" dirty="0">
                         <a:latin typeface="Consolas" charset="0"/>
@@ -10296,7 +10296,7 @@
                           <a:ea typeface="Calibri" pitchFamily="34" charset="-122"/>
                           <a:cs typeface="Calibri" pitchFamily="34" charset="-120"/>
                         </a:rPr>
-                        <a:t>Postgres</a:t>
+                        <a:t>Postgres*</a:t>
                       </a:r>
                       <a:endParaRPr lang="en-US" sz="1100" dirty="0">
                         <a:latin typeface="Calibri" charset="0"/>
@@ -10361,7 +10361,7 @@
                           <a:ea typeface="Consolas" pitchFamily="34" charset="-122"/>
                           <a:cs typeface="Consolas" pitchFamily="34" charset="-120"/>
                         </a:rPr>
-                        <a:t>1.84x</a:t>
+                        <a:t>2.25x</a:t>
                       </a:r>
                       <a:endParaRPr lang="en-US" sz="1100" dirty="0">
                         <a:latin typeface="Consolas" charset="0"/>
@@ -10623,7 +10623,7 @@
                           <a:ea typeface="Consolas" pitchFamily="34" charset="-122"/>
                           <a:cs typeface="Consolas" pitchFamily="34" charset="-120"/>
                         </a:rPr>
-                        <a:t>749.6</a:t>
+                        <a:t>711.7</a:t>
                       </a:r>
                       <a:endParaRPr lang="en-US" sz="1100" dirty="0">
                         <a:latin typeface="Consolas" charset="0"/>
@@ -10688,7 +10688,7 @@
                           <a:ea typeface="Consolas" pitchFamily="34" charset="-122"/>
                           <a:cs typeface="Consolas" pitchFamily="34" charset="-120"/>
                         </a:rPr>
-                        <a:t>9.9</a:t>
+                        <a:t>8.0</a:t>
                       </a:r>
                       <a:endParaRPr lang="en-US" sz="1100" dirty="0">
                         <a:latin typeface="Consolas" charset="0"/>
@@ -10753,7 +10753,7 @@
                           <a:ea typeface="Calibri" pitchFamily="34" charset="-122"/>
                           <a:cs typeface="Calibri" pitchFamily="34" charset="-120"/>
                         </a:rPr>
-                        <a:t>Neo4j</a:t>
+                        <a:t>Neo4j*</a:t>
                       </a:r>
                       <a:endParaRPr lang="en-US" sz="1100" dirty="0">
                         <a:latin typeface="Calibri" charset="0"/>
@@ -10818,7 +10818,7 @@
                           <a:ea typeface="Consolas" pitchFamily="34" charset="-122"/>
                           <a:cs typeface="Consolas" pitchFamily="34" charset="-120"/>
                         </a:rPr>
-                        <a:t>75.91x</a:t>
+                        <a:t>89.31x</a:t>
                       </a:r>
                       <a:endParaRPr lang="en-US" sz="1100" dirty="0">
                         <a:latin typeface="Consolas" charset="0"/>
@@ -11080,7 +11080,7 @@
                           <a:ea typeface="Consolas" pitchFamily="34" charset="-122"/>
                           <a:cs typeface="Consolas" pitchFamily="34" charset="-120"/>
                         </a:rPr>
-                        <a:t>363.9</a:t>
+                        <a:t>411.2</a:t>
                       </a:r>
                       <a:endParaRPr lang="en-US" sz="1100" dirty="0">
                         <a:latin typeface="Consolas" charset="0"/>
@@ -11145,7 +11145,7 @@
                           <a:ea typeface="Consolas" pitchFamily="34" charset="-122"/>
                           <a:cs typeface="Consolas" pitchFamily="34" charset="-120"/>
                         </a:rPr>
-                        <a:t>155.2</a:t>
+                        <a:t>168.2</a:t>
                       </a:r>
                       <a:endParaRPr lang="en-US" sz="1100" dirty="0">
                         <a:latin typeface="Consolas" charset="0"/>
@@ -11210,7 +11210,7 @@
                           <a:ea typeface="Calibri" pitchFamily="34" charset="-122"/>
                           <a:cs typeface="Calibri" pitchFamily="34" charset="-120"/>
                         </a:rPr>
-                        <a:t>Neo4j</a:t>
+                        <a:t>Neo4j*</a:t>
                       </a:r>
                       <a:endParaRPr lang="en-US" sz="1100" dirty="0">
                         <a:latin typeface="Calibri" charset="0"/>
@@ -11275,7 +11275,7 @@
                           <a:ea typeface="Consolas" pitchFamily="34" charset="-122"/>
                           <a:cs typeface="Consolas" pitchFamily="34" charset="-120"/>
                         </a:rPr>
-                        <a:t>2.34x</a:t>
+                        <a:t>2.44x</a:t>
                       </a:r>
                       <a:endParaRPr lang="en-US" sz="1100" dirty="0">
                         <a:latin typeface="Consolas" charset="0"/>
@@ -11537,7 +11537,7 @@
                           <a:ea typeface="Consolas" pitchFamily="34" charset="-122"/>
                           <a:cs typeface="Consolas" pitchFamily="34" charset="-120"/>
                         </a:rPr>
-                        <a:t>390.8</a:t>
+                        <a:t>443.4</a:t>
                       </a:r>
                       <a:endParaRPr lang="en-US" sz="1100" dirty="0">
                         <a:latin typeface="Consolas" charset="0"/>
@@ -11602,7 +11602,7 @@
                           <a:ea typeface="Consolas" pitchFamily="34" charset="-122"/>
                           <a:cs typeface="Consolas" pitchFamily="34" charset="-120"/>
                         </a:rPr>
-                        <a:t>33.2</a:t>
+                        <a:t>32.4</a:t>
                       </a:r>
                       <a:endParaRPr lang="en-US" sz="1100" dirty="0">
                         <a:latin typeface="Consolas" charset="0"/>
@@ -11667,7 +11667,7 @@
                           <a:ea typeface="Calibri" pitchFamily="34" charset="-122"/>
                           <a:cs typeface="Calibri" pitchFamily="34" charset="-120"/>
                         </a:rPr>
-                        <a:t>Neo4j</a:t>
+                        <a:t>Neo4j*</a:t>
                       </a:r>
                       <a:endParaRPr lang="en-US" sz="1100" dirty="0">
                         <a:latin typeface="Calibri" charset="0"/>
@@ -11732,7 +11732,7 @@
                           <a:ea typeface="Consolas" pitchFamily="34" charset="-122"/>
                           <a:cs typeface="Consolas" pitchFamily="34" charset="-120"/>
                         </a:rPr>
-                        <a:t>11.77x</a:t>
+                        <a:t>13.70x</a:t>
                       </a:r>
                       <a:endParaRPr lang="en-US" sz="1100" dirty="0">
                         <a:latin typeface="Consolas" charset="0"/>
@@ -12543,7 +12543,7 @@
                 <a:ea typeface="Calibri" pitchFamily="34" charset="-122"/>
                 <a:cs typeface="Calibri" pitchFamily="34" charset="-120"/>
               </a:rPr>
-              <a:t>76x</a:t>
+              <a:t>89x</a:t>
             </a:r>
             <a:endParaRPr lang="en-US" sz="8400" dirty="0"/>
           </a:p>
@@ -12621,7 +12621,7 @@
                 <a:ea typeface="Consolas" pitchFamily="34" charset="-122"/>
                 <a:cs typeface="Consolas" pitchFamily="34" charset="-120"/>
               </a:rPr>
-              <a:t>Postgres: 750 ms  |  Neo4j: 10 ms</a:t>
+              <a:t>Postgres: 712 ms  |  Neo4j: 8 ms</a:t>
             </a:r>
             <a:endParaRPr lang="en-US" sz="1200" dirty="0"/>
           </a:p>
@@ -13090,7 +13090,7 @@
                 <a:ea typeface="Calibri" pitchFamily="34" charset="-122"/>
                 <a:cs typeface="Calibri" pitchFamily="34" charset="-120"/>
               </a:rPr>
-              <a:t>Q10:  </a:t>
+              <a:t>Q10:  21 SQL lines vs 3 Cypher lines  (7×)  ·  26 SQL operators vs 3 Cypher operators  (8.7×).  Cypher wins on both axes — and dramatically.</a:t>
             </a:r>
             <a:pPr indent="0" marL="0">
               <a:buNone/>
@@ -13104,7 +13104,7 @@
                 <a:ea typeface="Calibri" pitchFamily="34" charset="-122"/>
                 <a:cs typeface="Calibri" pitchFamily="34" charset="-120"/>
               </a:rPr>
-              <a:t>30 SQL lines vs 3 Cypher lines  </a:t>
+              <a:t/>
             </a:r>
             <a:pPr indent="0" marL="0">
               <a:buNone/>
@@ -13118,7 +13118,7 @@
                 <a:ea typeface="Calibri" pitchFamily="34" charset="-122"/>
                 <a:cs typeface="Calibri" pitchFamily="34" charset="-120"/>
               </a:rPr>
-              <a:t>(10×)</a:t>
+              <a:t/>
             </a:r>
             <a:pPr indent="0" marL="0">
               <a:buNone/>
@@ -13132,7 +13132,7 @@
                 <a:ea typeface="Calibri" pitchFamily="34" charset="-122"/>
                 <a:cs typeface="Calibri" pitchFamily="34" charset="-120"/>
               </a:rPr>
-              <a:t>  ·  </a:t>
+              <a:t/>
             </a:r>
             <a:pPr indent="0" marL="0">
               <a:buNone/>
@@ -13146,7 +13146,7 @@
                 <a:ea typeface="Calibri" pitchFamily="34" charset="-122"/>
                 <a:cs typeface="Calibri" pitchFamily="34" charset="-120"/>
               </a:rPr>
-              <a:t>28 SQL operators vs 3 Cypher operators  </a:t>
+              <a:t/>
             </a:r>
             <a:pPr indent="0" marL="0">
               <a:buNone/>
@@ -13160,7 +13160,7 @@
                 <a:ea typeface="Calibri" pitchFamily="34" charset="-122"/>
                 <a:cs typeface="Calibri" pitchFamily="34" charset="-120"/>
               </a:rPr>
-              <a:t>(9.3×)</a:t>
+              <a:t/>
             </a:r>
             <a:pPr indent="0" marL="0">
               <a:buNone/>
@@ -13174,7 +13174,7 @@
                 <a:ea typeface="Calibri" pitchFamily="34" charset="-122"/>
                 <a:cs typeface="Calibri" pitchFamily="34" charset="-120"/>
               </a:rPr>
-              <a:t>.  Cypher wins on both axes — and dramatically.</a:t>
+              <a:t/>
             </a:r>
             <a:endParaRPr lang="en-US" sz="1100" dirty="0"/>
           </a:p>
@@ -14170,9 +14170,9 @@
                 <a:ea typeface="Calibri" pitchFamily="34" charset="-122"/>
                 <a:cs typeface="Calibri" pitchFamily="34" charset="-120"/>
               </a:rPr>
-              <a:t>30 lines  →  3 lines
-750 ms   →  10 ms
-28 ops    →  3 ops</a:t>
+              <a:t>21 lines  →  3 lines
+712 ms   →  8 ms
+26 ops    →  3 ops</a:t>
             </a:r>
             <a:endParaRPr lang="en-US" sz="2200" dirty="0"/>
           </a:p>
@@ -15227,7 +15227,7 @@
                 <a:ea typeface="Calibri" pitchFamily="34" charset="-122"/>
                 <a:cs typeface="Calibri" pitchFamily="34" charset="-120"/>
               </a:rPr>
-              <a:t>Drop one critical index, watch the world burn</a:t>
+              <a:t>7 ablation targets across both systems — drop, measure, restore</a:t>
             </a:r>
             <a:endParaRPr lang="en-US" sz="1300" dirty="0"/>
           </a:p>
@@ -15295,7 +15295,7 @@
                 <a:ea typeface="Calibri" pitchFamily="34" charset="-122"/>
                 <a:cs typeface="Calibri" pitchFamily="34" charset="-120"/>
               </a:rPr>
-              <a:t>We ran Q08 (teammates of Messi) three times on each system: with the index, without, and with it back.</a:t>
+              <a:t>We ran 7 index-query pairs (4 PG + 3 Neo4j) — each dropped, measured over 10 runs, then restored.</a:t>
             </a:r>
             <a:endParaRPr lang="en-US" sz="1200" dirty="0"/>
           </a:p>
@@ -15555,7 +15555,7 @@
                 <a:ea typeface="Calibri" pitchFamily="34" charset="-122"/>
                 <a:cs typeface="Calibri" pitchFamily="34" charset="-120"/>
               </a:rPr>
-              <a:t>3.6 ms</a:t>
+              <a:t>3.2 ms</a:t>
             </a:r>
             <a:endParaRPr lang="en-US" sz="2200" dirty="0"/>
           </a:p>
@@ -15633,7 +15633,7 @@
                 <a:ea typeface="Calibri" pitchFamily="34" charset="-122"/>
                 <a:cs typeface="Calibri" pitchFamily="34" charset="-120"/>
               </a:rPr>
-              <a:t>11.3 ms</a:t>
+              <a:t>11.2 ms</a:t>
             </a:r>
             <a:endParaRPr lang="en-US" sz="2200" dirty="0"/>
           </a:p>
@@ -15672,7 +15672,7 @@
                 <a:ea typeface="Calibri" pitchFamily="34" charset="-122"/>
                 <a:cs typeface="Calibri" pitchFamily="34" charset="-120"/>
               </a:rPr>
-              <a:t>(measured · 5 runs median)</a:t>
+              <a:t>(measured · 10 runs median)</a:t>
             </a:r>
             <a:endParaRPr lang="en-US" sz="900" dirty="0"/>
           </a:p>
@@ -15932,7 +15932,7 @@
                 <a:ea typeface="Calibri" pitchFamily="34" charset="-122"/>
                 <a:cs typeface="Calibri" pitchFamily="34" charset="-120"/>
               </a:rPr>
-              <a:t>5.1 ms</a:t>
+              <a:t>3.9 ms</a:t>
             </a:r>
             <a:endParaRPr lang="en-US" sz="2200" dirty="0"/>
           </a:p>
@@ -16010,7 +16010,7 @@
                 <a:ea typeface="Calibri" pitchFamily="34" charset="-122"/>
                 <a:cs typeface="Calibri" pitchFamily="34" charset="-120"/>
               </a:rPr>
-              <a:t>7.8 ms</a:t>
+              <a:t>7.4 ms</a:t>
             </a:r>
             <a:endParaRPr lang="en-US" sz="2200" dirty="0"/>
           </a:p>
@@ -16049,7 +16049,7 @@
                 <a:ea typeface="Calibri" pitchFamily="34" charset="-122"/>
                 <a:cs typeface="Calibri" pitchFamily="34" charset="-120"/>
               </a:rPr>
-              <a:t>(measured · 5 runs median)</a:t>
+              <a:t>(measured · 10 runs median)</a:t>
             </a:r>
             <a:endParaRPr lang="en-US" sz="900" dirty="0"/>
           </a:p>
@@ -16088,7 +16088,7 @@
                 <a:ea typeface="Calibri" pitchFamily="34" charset="-122"/>
                 <a:cs typeface="Calibri" pitchFamily="34" charset="-120"/>
               </a:rPr>
-              <a:t>Postgres: 3.18× slowdown without ix_lineup_player  ·  Neo4j: 1.55× slowdown without player_name_idx</a:t>
+              <a:t>Postgres: 3.48× slowdown without ix_lineup_player  ·  Neo4j: 1.91× slowdown without player_name_idx</a:t>
             </a:r>
             <a:endParaRPr lang="en-US" sz="1100" dirty="0"/>
           </a:p>
@@ -16698,7 +16698,7 @@
                 <a:ea typeface="Calibri" pitchFamily="34" charset="-122"/>
                 <a:cs typeface="Calibri" pitchFamily="34" charset="-120"/>
               </a:rPr>
-              <a:t>Multi-hop traversal, shortest path, presence-in-all-of: Q07 (6.4×), Q10 (76×). And the Cypher code is dramatically more concise.</a:t>
+              <a:t>Multi-hop traversal, shortest path, presence-in-all-of: Q07 (6.2×), Q10 (89×). And the Cypher code is dramatically more concise.</a:t>
             </a:r>
             <a:endParaRPr lang="en-US" sz="1100" dirty="0"/>
           </a:p>
@@ -17708,45 +17708,6 @@
       </p:sp>
       <p:sp>
         <p:nvSpPr>
-          <p:cNvPr id="26" name="Text 24"/>
-          <p:cNvSpPr/>
-          <p:nvPr/>
-        </p:nvSpPr>
-        <p:spPr>
-          <a:xfrm>
-            <a:off x="457200" y="4572000"/>
-            <a:ext cx="8229600" cy="274320"/>
-          </a:xfrm>
-          <a:prstGeom prst="rect">
-            <a:avLst/>
-          </a:prstGeom>
-          <a:noFill/>
-          <a:ln/>
-        </p:spPr>
-        <p:txBody>
-          <a:bodyPr wrap="square" lIns="0" tIns="0" rIns="0" bIns="0" rtlCol="0" anchor="ctr"/>
-          <a:lstStyle/>
-          <a:p>
-            <a:pPr algn="ctr" indent="0" marL="0">
-              <a:buNone/>
-            </a:pPr>
-            <a:r>
-              <a:rPr lang="en-US" sz="1100" i="1" dirty="0">
-                <a:solidFill>
-                  <a:srgbClr val="64748B"/>
-                </a:solidFill>
-                <a:latin typeface="Calibri" pitchFamily="34" charset="0"/>
-                <a:ea typeface="Calibri" pitchFamily="34" charset="-122"/>
-                <a:cs typeface="Calibri" pitchFamily="34" charset="-120"/>
-              </a:rPr>
-              <a:t>Postgres: 3.25× slowdown without ix_lineup_player  ·  Neo4j: 2.32× slowdown without player_name_idx</a:t>
-            </a:r>
-            <a:endParaRPr lang="en-US" sz="1100" dirty="0"/>
-          </a:p>
-        </p:txBody>
-      </p:sp>
-      <p:sp>
-        <p:nvSpPr>
           <p:cNvPr id="27" name="Shape 25"/>
           <p:cNvSpPr/>
           <p:nvPr/>
@@ -17971,7 +17932,7 @@
           <a:p>
             <a:r>
               <a:rPr sz="1200"/>
-              <a:t>Both engines run on default configuration. Tuning shared_buffers / work_mem (Postgres) or pagecache.size (Neo4j) could shift results.</a:t>
+              <a:t>Default configs on both engines. work_mem tested on Q07: no effect (report, sez. 10). A shared_buffers / pagecache grid could still shift the close category-A races.</a:t>
             </a:r>
           </a:p>
         </p:txBody>
@@ -19584,45 +19545,6 @@
       </p:sp>
       <p:sp>
         <p:nvSpPr>
-          <p:cNvPr id="26" name="Text 24"/>
-          <p:cNvSpPr/>
-          <p:nvPr/>
-        </p:nvSpPr>
-        <p:spPr>
-          <a:xfrm>
-            <a:off x="457200" y="4572000"/>
-            <a:ext cx="8229600" cy="274320"/>
-          </a:xfrm>
-          <a:prstGeom prst="rect">
-            <a:avLst/>
-          </a:prstGeom>
-          <a:noFill/>
-          <a:ln/>
-        </p:spPr>
-        <p:txBody>
-          <a:bodyPr wrap="square" lIns="0" tIns="0" rIns="0" bIns="0" rtlCol="0" anchor="ctr"/>
-          <a:lstStyle/>
-          <a:p>
-            <a:pPr algn="ctr" indent="0" marL="0">
-              <a:buNone/>
-            </a:pPr>
-            <a:r>
-              <a:rPr lang="en-US" sz="1100" i="1" dirty="0">
-                <a:solidFill>
-                  <a:srgbClr val="64748B"/>
-                </a:solidFill>
-                <a:latin typeface="Calibri" pitchFamily="34" charset="0"/>
-                <a:ea typeface="Calibri" pitchFamily="34" charset="-122"/>
-                <a:cs typeface="Calibri" pitchFamily="34" charset="-120"/>
-              </a:rPr>
-              <a:t>Postgres: 3.25× slowdown without ix_lineup_player  ·  Neo4j: 2.32× slowdown without player_name_idx</a:t>
-            </a:r>
-            <a:endParaRPr lang="en-US" sz="1100" dirty="0"/>
-          </a:p>
-        </p:txBody>
-      </p:sp>
-      <p:sp>
-        <p:nvSpPr>
           <p:cNvPr id="27" name="Shape 25"/>
           <p:cNvSpPr/>
           <p:nvPr/>
@@ -27092,7 +27014,7 @@
           <a:p>
             <a:r>
               <a:rPr sz="1200"/>
-              <a:t>5 measured runs per query  +  1 warm-up discarded  ·  Median, min, max, IQR  ·  Result equality verified as set of normalised tuples.</a:t>
+              <a:t>15 measured runs per query + 1 warm-up discarded  ·  Median with bootstrap 95% CI (10,000 resamples)  ·  Mann-Whitney U significance test (alpha = 0.05)  ·  Result equality verified as normalised tuples.</a:t>
             </a:r>
           </a:p>
         </p:txBody>

</xml_diff>